<commit_message>
Add click-triggered callout badge on slide 4
Pink callout bubble with "PRIORIDAD MANEJO DE TABLET Y REGISTRO"
appears centered after a click, with fade entrance animation.
</commit_message>
<xml_diff>
--- a/santa-lucia/Caso2_Presentacion_Javier_2_1_mejorada.pptx
+++ b/santa-lucia/Caso2_Presentacion_Javier_2_1_mejorada.pptx
@@ -11987,6 +11987,55 @@
           </p:txBody>
         </p:sp>
       </p:grpSp>
+      <p:sp>
+        <p:nvSpPr>
+          <p:cNvPr id="327" name="PrioridadBadge"/>
+          <p:cNvSpPr/>
+          <p:nvPr/>
+        </p:nvSpPr>
+        <p:spPr>
+          <a:xfrm>
+            <a:off x="1996000" y="4800000"/>
+            <a:ext cx="8200000" cy="1100000"/>
+          </a:xfrm>
+          <a:prstGeom prst="wedgeRoundRectCallout">
+            <a:avLst>
+              <a:gd name="adj1" fmla="val -35000"/>
+              <a:gd name="adj2" fmla="val 75000"/>
+              <a:gd name="adj3" fmla="val 16667"/>
+            </a:avLst>
+          </a:prstGeom>
+          <a:solidFill>
+            <a:srgbClr val="D81B7A"/>
+          </a:solidFill>
+          <a:ln w="0">
+            <a:noFill/>
+          </a:ln>
+          <a:effectLst>
+            <a:outerShdw blurRad="152400" dist="38100" dir="5400000" algn="bl" rotWithShape="0">
+              <a:srgbClr val="000000">
+                <a:alpha val="22000"/>
+              </a:srgbClr>
+            </a:outerShdw>
+          </a:effectLst>
+        </p:spPr>
+        <p:txBody>
+          <a:bodyPr wrap="square" lIns="182880" tIns="91440" rIns="182880" bIns="91440" anchor="ctr"/>
+          <a:lstStyle/>
+          <a:p>
+            <a:pPr algn="ctr"/>
+            <a:r>
+              <a:rPr lang="es-ES" sz="2400" b="1" kern="0" spc="200" dirty="0">
+                <a:solidFill>
+                  <a:srgbClr val="FFFFFF"/>
+                </a:solidFill>
+                <a:latin typeface="Calibri" pitchFamily="34" charset="0"/>
+              </a:rPr>
+              <a:t>PRIORIDAD MANEJO DE TABLET Y REGISTRO</a:t>
+            </a:r>
+          </a:p>
+        </p:txBody>
+      </p:sp>
     </p:spTree>
   </p:cSld>
   <p:clrMapOvr>
@@ -12201,6 +12250,55 @@
                                         <p:cTn id="324" dur="400" fill="hold"/>
                                         <p:tgtEl>
                                           <p:spTgt spid="8"/>
+                                        </p:tgtEl>
+                                      </p:cBhvr>
+                                    </p:animEffect>
+                                  </p:childTnLst>
+                                </p:cTn>
+                              </p:par>
+                            </p:childTnLst>
+                          </p:cTn>
+                        </p:par>
+                      </p:childTnLst>
+                    </p:cTn>
+                  </p:par>
+                  <p:par>
+                    <p:cTn id="500" fill="hold">
+                      <p:stCondLst>
+                        <p:cond delay="indefinite"/>
+                      </p:stCondLst>
+                      <p:childTnLst>
+                        <p:par>
+                          <p:cTn id="501" fill="hold">
+                            <p:stCondLst>
+                              <p:cond delay="0"/>
+                            </p:stCondLst>
+                            <p:childTnLst>
+                              <p:par>
+                                <p:cTn id="502" presetID="53" presetClass="entr" presetSubtype="0" fill="hold" grpId="0" nodeType="clickEffect">
+                                  <p:stCondLst>
+                                    <p:cond delay="0"/>
+                                  </p:stCondLst>
+                                  <p:childTnLst>
+                                    <p:set>
+                                      <p:cBhvr>
+                                        <p:cTn id="503" dur="1" fill="hold"/>
+                                        <p:tgtEl>
+                                          <p:spTgt spid="327"/>
+                                        </p:tgtEl>
+                                        <p:attrNameLst>
+                                          <p:attrName>style.visibility</p:attrName>
+                                        </p:attrNameLst>
+                                      </p:cBhvr>
+                                      <p:to>
+                                        <p:strVal val="visible"/>
+                                      </p:to>
+                                    </p:set>
+                                    <p:animEffect transition="in" filter="fade">
+                                      <p:cBhvr>
+                                        <p:cTn id="504" dur="700" fill="hold"/>
+                                        <p:tgtEl>
+                                          <p:spTgt spid="327"/>
                                         </p:tgtEl>
                                       </p:cBhvr>
                                     </p:animEffect>

</xml_diff>